<commit_message>
Lezione 8: versioni aggiornate delle azioni GitHub
</commit_message>
<xml_diff>
--- a/slide/slide-8-deploy.pptx
+++ b/slide/slide-8-deploy.pptx
@@ -21514,7 +21514,7 @@
                 <a:ea typeface="Courier New" pitchFamily="34" charset="-122"/>
                 <a:cs typeface="Courier New" pitchFamily="34" charset="-120"/>
               </a:rPr>
-              <a:t>      - uses: actions/checkout@v4</a:t>
+              <a:t>      - uses: actions/checkout@v7</a:t>
             </a:r>
             <a:endParaRPr lang="en-US" sz="1600" dirty="0"/>
           </a:p>
@@ -21531,7 +21531,7 @@
                 <a:ea typeface="Courier New" pitchFamily="34" charset="-122"/>
                 <a:cs typeface="Courier New" pitchFamily="34" charset="-120"/>
               </a:rPr>
-              <a:t>      - uses: aws-actions/configure-aws-credentials@v4</a:t>
+              <a:t>      - uses: aws-actions/configure-aws-credentials@v6</a:t>
             </a:r>
             <a:endParaRPr lang="en-US" sz="1600" dirty="0"/>
           </a:p>
@@ -21616,7 +21616,7 @@
                 <a:ea typeface="Courier New" pitchFamily="34" charset="-122"/>
                 <a:cs typeface="Courier New" pitchFamily="34" charset="-120"/>
               </a:rPr>
-              <a:t>      - uses: docker/setup-qemu-action@v3      </a:t>
+              <a:t>      - uses: docker/setup-qemu-action@v4      </a:t>
             </a:r>
             <a:pPr indent="0" marL="0">
               <a:buNone/>
@@ -21647,7 +21647,7 @@
                 <a:ea typeface="Courier New" pitchFamily="34" charset="-122"/>
                 <a:cs typeface="Courier New" pitchFamily="34" charset="-120"/>
               </a:rPr>
-              <a:t>      - uses: docker/setup-buildx-action@v3</a:t>
+              <a:t>      - uses: docker/setup-buildx-action@v4</a:t>
             </a:r>
             <a:endParaRPr lang="en-US" sz="1600" dirty="0"/>
           </a:p>
@@ -21664,7 +21664,7 @@
                 <a:ea typeface="Courier New" pitchFamily="34" charset="-122"/>
                 <a:cs typeface="Courier New" pitchFamily="34" charset="-120"/>
               </a:rPr>
-              <a:t>      - uses: docker/build-push-action@v6</a:t>
+              <a:t>      - uses: docker/build-push-action@v7</a:t>
             </a:r>
             <a:endParaRPr lang="en-US" sz="1600" dirty="0"/>
           </a:p>

</xml_diff>